<commit_message>
Resize FCF chart to fit the Company Health column
Co-Authored-By: Claude Opus 5.5 <noreply@anthropic.com>
Claude-Session: https://claude.ai/code/session_01Cj79ASkpMEuE6e5NkxXNtw
</commit_message>
<xml_diff>
--- a/DKS_FCF_Chart.pptx
+++ b/DKS_FCF_Chart.pptx
@@ -152,10 +152,12 @@
               <c:strCache>
                 <c:ptCount val="2"/>
                 <c:pt idx="0">
-                  <c:v>Dividends + buybacks</c:v>
+                  <c:v>Dividends +
+buybacks</c:v>
                 </c:pt>
                 <c:pt idx="1">
-                  <c:v>Free cash flow</c:v>
+                  <c:v>Free cash
+flow</c:v>
                 </c:pt>
               </c:strCache>
             </c:strRef>
@@ -183,7 +185,7 @@
             <a:lstStyle/>
             <a:p>
               <a:pPr>
-                <a:defRPr sz="1000">
+                <a:defRPr sz="900">
                   <a:solidFill>
                     <a:srgbClr val="000000"/>
                   </a:solidFill>
@@ -225,7 +227,7 @@
           <a:lstStyle/>
           <a:p>
             <a:pPr>
-              <a:defRPr sz="1000">
+              <a:defRPr sz="900">
                 <a:solidFill>
                   <a:srgbClr val="666666"/>
                 </a:solidFill>
@@ -244,7 +246,7 @@
       <c:valAx>
         <c:axId val="-2113994440"/>
         <c:scaling>
-          <c:max val="430.0"/>
+          <c:max val="450.0"/>
           <c:min val="0.0"/>
         </c:scaling>
         <c:delete/>
@@ -3263,8 +3265,8 @@
         </p:nvSpPr>
         <p:spPr>
           <a:xfrm>
-            <a:off x="457200" y="457200"/>
-            <a:ext cx="4023360" cy="274320"/>
+            <a:off x="3200400" y="3703320"/>
+            <a:ext cx="2743200" cy="274320"/>
           </a:xfrm>
           <a:prstGeom prst="rect">
             <a:avLst/>
@@ -3272,14 +3274,14 @@
           <a:noFill/>
         </p:spPr>
         <p:txBody>
-          <a:bodyPr wrap="none">
+          <a:bodyPr wrap="none" lIns="0" rIns="0">
             <a:spAutoFit/>
           </a:bodyPr>
           <a:lstStyle/>
           <a:p>
             <a:pPr algn="ctr"/>
             <a:r>
-              <a:rPr sz="1100">
+              <a:rPr sz="1000">
                 <a:solidFill>
                   <a:srgbClr val="000000"/>
                 </a:solidFill>
@@ -3299,8 +3301,8 @@
           <p:nvPr/>
         </p:nvGraphicFramePr>
         <p:xfrm>
-          <a:off x="457200" y="731520"/>
-          <a:ext cx="4023360" cy="1463040"/>
+          <a:off x="3200400" y="3959352"/>
+          <a:ext cx="2743200" cy="1280160"/>
         </p:xfrm>
         <a:graphic>
           <a:graphicData uri="http://schemas.openxmlformats.org/drawingml/2006/chart">
@@ -3316,8 +3318,8 @@
         </p:nvSpPr>
         <p:spPr>
           <a:xfrm>
-            <a:off x="457200" y="2240280"/>
-            <a:ext cx="4023360" cy="274320"/>
+            <a:off x="3200400" y="5239512"/>
+            <a:ext cx="2743200" cy="228600"/>
           </a:xfrm>
           <a:prstGeom prst="rect">
             <a:avLst/>
@@ -3325,14 +3327,14 @@
           <a:noFill/>
         </p:spPr>
         <p:txBody>
-          <a:bodyPr wrap="none">
+          <a:bodyPr wrap="none" lIns="0" rIns="0">
             <a:spAutoFit/>
           </a:bodyPr>
           <a:lstStyle/>
           <a:p>
             <a:pPr algn="ctr"/>
             <a:r>
-              <a:rPr b="0" sz="900">
+              <a:rPr b="0" sz="850">
                 <a:solidFill>
                   <a:srgbClr val="666666"/>
                 </a:solidFill>
@@ -3341,7 +3343,7 @@
               <a:t>Dividends $225M + buybacks $141M = </a:t>
             </a:r>
             <a:r>
-              <a:rPr b="1" sz="900">
+              <a:rPr b="1" sz="850">
                 <a:solidFill>
                   <a:srgbClr val="000000"/>
                 </a:solidFill>
@@ -3360,8 +3362,8 @@
         </p:nvSpPr>
         <p:spPr>
           <a:xfrm>
-            <a:off x="457200" y="2468880"/>
-            <a:ext cx="4023360" cy="228600"/>
+            <a:off x="3200400" y="5440680"/>
+            <a:ext cx="2743200" cy="201168"/>
           </a:xfrm>
           <a:prstGeom prst="rect">
             <a:avLst/>
@@ -3369,20 +3371,20 @@
           <a:noFill/>
         </p:spPr>
         <p:txBody>
-          <a:bodyPr wrap="none">
+          <a:bodyPr wrap="none" lIns="0" rIns="0">
             <a:spAutoFit/>
           </a:bodyPr>
           <a:lstStyle/>
           <a:p>
             <a:pPr algn="ctr"/>
             <a:r>
-              <a:rPr sz="700" i="1">
+              <a:rPr sz="650" i="1">
                 <a:solidFill>
                   <a:srgbClr val="666666"/>
                 </a:solidFill>
                 <a:latin typeface="Garamond"/>
               </a:rPr>
-              <a:t>FCF = operating cash flow $792M – net capex $614M. Team calculation from H1 FY26 cash flows</a:t>
+              <a:t>FCF = op. cash flow $792M – net capex $614M (team calc.)</a:t>
             </a:r>
           </a:p>
         </p:txBody>

</xml_diff>

<commit_message>
Fit FCF chart to the Company Health column on the overview slide
Co-Authored-By: Claude Opus 5.5 <noreply@anthropic.com>
Claude-Session: https://claude.ai/code/session_01Cj79ASkpMEuE6e5NkxXNtw
</commit_message>
<xml_diff>
--- a/DKS_FCF_Chart.pptx
+++ b/DKS_FCF_Chart.pptx
@@ -185,7 +185,7 @@
             <a:lstStyle/>
             <a:p>
               <a:pPr>
-                <a:defRPr sz="900">
+                <a:defRPr sz="1200">
                   <a:solidFill>
                     <a:srgbClr val="000000"/>
                   </a:solidFill>
@@ -203,7 +203,7 @@
           <c:showBubbleSize val="0"/>
           <c:showLeaderLines val="1"/>
         </c:dLbls>
-        <c:gapWidth val="60"/>
+        <c:gapWidth val="40"/>
         <c:axId val="-2068027336"/>
         <c:axId val="-2113994440"/>
       </c:barChart>
@@ -227,7 +227,7 @@
           <a:lstStyle/>
           <a:p>
             <a:pPr>
-              <a:defRPr sz="900">
+              <a:defRPr sz="1100">
                 <a:solidFill>
                   <a:srgbClr val="666666"/>
                 </a:solidFill>
@@ -246,7 +246,7 @@
       <c:valAx>
         <c:axId val="-2113994440"/>
         <c:scaling>
-          <c:max val="450.0"/>
+          <c:max val="415.0"/>
           <c:min val="0.0"/>
         </c:scaling>
         <c:delete/>
@@ -3265,7 +3265,7 @@
         </p:nvSpPr>
         <p:spPr>
           <a:xfrm>
-            <a:off x="3200400" y="3703320"/>
+            <a:off x="3191256" y="3703320"/>
             <a:ext cx="2743200" cy="274320"/>
           </a:xfrm>
           <a:prstGeom prst="rect">
@@ -3281,13 +3281,13 @@
           <a:p>
             <a:pPr algn="ctr"/>
             <a:r>
-              <a:rPr sz="1000">
+              <a:rPr sz="1300">
                 <a:solidFill>
                   <a:srgbClr val="000000"/>
                 </a:solidFill>
                 <a:latin typeface="Garamond"/>
               </a:rPr>
-              <a:t>H1 FY26: Cash Returned vs. Free Cash Flow ($M)</a:t>
+              <a:t>H1 FY26 Free Cash Flow vs. Payouts</a:t>
             </a:r>
           </a:p>
         </p:txBody>
@@ -3301,8 +3301,8 @@
           <p:nvPr/>
         </p:nvGraphicFramePr>
         <p:xfrm>
-          <a:off x="3200400" y="3959352"/>
-          <a:ext cx="2743200" cy="1280160"/>
+          <a:off x="3191256" y="4023360"/>
+          <a:ext cx="2743200" cy="1600200"/>
         </p:xfrm>
         <a:graphic>
           <a:graphicData uri="http://schemas.openxmlformats.org/drawingml/2006/chart">
@@ -3318,8 +3318,8 @@
         </p:nvSpPr>
         <p:spPr>
           <a:xfrm>
-            <a:off x="3200400" y="5239512"/>
-            <a:ext cx="2743200" cy="228600"/>
+            <a:off x="3191256" y="5641848"/>
+            <a:ext cx="2743200" cy="246888"/>
           </a:xfrm>
           <a:prstGeom prst="rect">
             <a:avLst/>
@@ -3334,22 +3334,22 @@
           <a:p>
             <a:pPr algn="ctr"/>
             <a:r>
-              <a:rPr b="0" sz="850">
+              <a:rPr b="0" sz="1050">
                 <a:solidFill>
                   <a:srgbClr val="666666"/>
                 </a:solidFill>
                 <a:latin typeface="Garamond"/>
               </a:rPr>
-              <a:t>Dividends $225M + buybacks $141M = </a:t>
-            </a:r>
-            <a:r>
-              <a:rPr b="1" sz="850">
+              <a:t>Dividends + buybacks = </a:t>
+            </a:r>
+            <a:r>
+              <a:rPr b="1" sz="1050">
                 <a:solidFill>
                   <a:srgbClr val="000000"/>
                 </a:solidFill>
                 <a:latin typeface="Garamond"/>
               </a:rPr>
-              <a:t>~2x free cash flow</a:t>
+              <a:t>~2x FCF</a:t>
             </a:r>
           </a:p>
         </p:txBody>
@@ -3362,7 +3362,7 @@
         </p:nvSpPr>
         <p:spPr>
           <a:xfrm>
-            <a:off x="3200400" y="5440680"/>
+            <a:off x="3191256" y="5897880"/>
             <a:ext cx="2743200" cy="201168"/>
           </a:xfrm>
           <a:prstGeom prst="rect">
@@ -3378,13 +3378,13 @@
           <a:p>
             <a:pPr algn="ctr"/>
             <a:r>
-              <a:rPr sz="650" i="1">
+              <a:rPr sz="800" i="1">
                 <a:solidFill>
                   <a:srgbClr val="666666"/>
                 </a:solidFill>
                 <a:latin typeface="Garamond"/>
               </a:rPr>
-              <a:t>FCF = op. cash flow $792M – net capex $614M (team calc.)</a:t>
+              <a:t>Dividends $225M + buybacks $141M; FCF = $792M OCF – $614M capex</a:t>
             </a:r>
           </a:p>
         </p:txBody>

</xml_diff>

<commit_message>
Restyle FCF chart to match deck's bar chart style
Co-Authored-By: Claude Opus 5.5 <noreply@anthropic.com>
Claude-Session: https://claude.ai/code/session_01Cj79ASkpMEuE6e5NkxXNtw
</commit_message>
<xml_diff>
--- a/DKS_FCF_Chart.pptx
+++ b/DKS_FCF_Chart.pptx
@@ -105,175 +105,6 @@
     </a:lvl9pPr>
   </p:defaultTextStyle>
 </p:presentation>
-</file>
-
-<file path=ppt/charts/chart1.xml><?xml version="1.0" encoding="utf-8"?>
-<c:chartSpace xmlns:c="http://schemas.openxmlformats.org/drawingml/2006/chart" xmlns:a="http://schemas.openxmlformats.org/drawingml/2006/main" xmlns:r="http://schemas.openxmlformats.org/officeDocument/2006/relationships">
-  <c:date1904 val="0"/>
-  <c:chart>
-    <c:autoTitleDeleted val="1"/>
-    <c:plotArea>
-      <c:barChart>
-        <c:barDir val="bar"/>
-        <c:grouping val="clustered"/>
-        <c:ser>
-          <c:idx val="0"/>
-          <c:order val="0"/>
-          <c:tx>
-            <c:strRef>
-              <c:f>Sheet1!$B$1</c:f>
-              <c:strCache>
-                <c:ptCount val="1"/>
-                <c:pt idx="0">
-                  <c:v>H1 FY26 ($M)</c:v>
-                </c:pt>
-              </c:strCache>
-            </c:strRef>
-          </c:tx>
-          <c:dPt>
-            <c:idx val="0"/>
-            <c:spPr>
-              <a:solidFill>
-                <a:srgbClr val="ED672B"/>
-              </a:solidFill>
-            </c:spPr>
-          </c:dPt>
-          <c:dPt>
-            <c:idx val="1"/>
-            <c:spPr>
-              <a:solidFill>
-                <a:srgbClr val="111E40"/>
-              </a:solidFill>
-            </c:spPr>
-          </c:dPt>
-          <c:cat>
-            <c:strRef>
-              <c:f>Sheet1!$A$2:$A$3</c:f>
-              <c:strCache>
-                <c:ptCount val="2"/>
-                <c:pt idx="0">
-                  <c:v>Dividends +
-buybacks</c:v>
-                </c:pt>
-                <c:pt idx="1">
-                  <c:v>Free cash
-flow</c:v>
-                </c:pt>
-              </c:strCache>
-            </c:strRef>
-          </c:cat>
-          <c:val>
-            <c:numRef>
-              <c:f>Sheet1!$B$2:$B$3</c:f>
-              <c:numCache>
-                <c:formatCode>General</c:formatCode>
-                <c:ptCount val="2"/>
-                <c:pt idx="0">
-                  <c:v>366</c:v>
-                </c:pt>
-                <c:pt idx="1">
-                  <c:v>178</c:v>
-                </c:pt>
-              </c:numCache>
-            </c:numRef>
-          </c:val>
-        </c:ser>
-        <c:dLbls>
-          <c:numFmt formatCode="&quot;$&quot;0&quot;M&quot;" sourceLinked="0"/>
-          <c:txPr>
-            <a:bodyPr/>
-            <a:lstStyle/>
-            <a:p>
-              <a:pPr>
-                <a:defRPr sz="1200">
-                  <a:solidFill>
-                    <a:srgbClr val="000000"/>
-                  </a:solidFill>
-                  <a:latin typeface="Garamond"/>
-                </a:defRPr>
-              </a:pPr>
-            </a:p>
-          </c:txPr>
-          <c:dLblPos val="outEnd"/>
-          <c:showLegendKey val="0"/>
-          <c:showVal val="1"/>
-          <c:showCatName val="0"/>
-          <c:showSerName val="0"/>
-          <c:showPercent val="0"/>
-          <c:showBubbleSize val="0"/>
-          <c:showLeaderLines val="1"/>
-        </c:dLbls>
-        <c:gapWidth val="40"/>
-        <c:axId val="-2068027336"/>
-        <c:axId val="-2113994440"/>
-      </c:barChart>
-      <c:catAx>
-        <c:axId val="-2068027336"/>
-        <c:scaling>
-          <c:orientation val="minMax"/>
-        </c:scaling>
-        <c:delete val="0"/>
-        <c:axPos val="l"/>
-        <c:majorTickMark val="out"/>
-        <c:minorTickMark val="none"/>
-        <c:tickLblPos val="nextTo"/>
-        <c:spPr>
-          <a:ln>
-            <a:noFill/>
-          </a:ln>
-        </c:spPr>
-        <c:txPr>
-          <a:bodyPr/>
-          <a:lstStyle/>
-          <a:p>
-            <a:pPr>
-              <a:defRPr sz="1100">
-                <a:solidFill>
-                  <a:srgbClr val="666666"/>
-                </a:solidFill>
-                <a:latin typeface="Garamond"/>
-              </a:defRPr>
-            </a:pPr>
-          </a:p>
-        </c:txPr>
-        <c:crossAx val="-2113994440"/>
-        <c:crosses val="autoZero"/>
-        <c:auto val="1"/>
-        <c:lblAlgn val="ctr"/>
-        <c:lblOffset val="100"/>
-        <c:noMultiLvlLbl val="0"/>
-      </c:catAx>
-      <c:valAx>
-        <c:axId val="-2113994440"/>
-        <c:scaling>
-          <c:max val="415.0"/>
-          <c:min val="0.0"/>
-        </c:scaling>
-        <c:delete/>
-        <c:axPos val="b"/>
-        <c:majorTickMark val="out"/>
-        <c:minorTickMark val="none"/>
-        <c:tickLblPos val="nextTo"/>
-        <c:crossAx val="-2068027336"/>
-        <c:crosses val="autoZero"/>
-      </c:valAx>
-    </c:plotArea>
-    <c:dispBlanksAs val="gap"/>
-  </c:chart>
-  <c:txPr>
-    <a:bodyPr/>
-    <a:lstStyle/>
-    <a:p>
-      <a:pPr>
-        <a:defRPr sz="1800"/>
-      </a:pPr>
-      <a:endParaRPr lang="en-US"/>
-    </a:p>
-  </c:txPr>
-  <c:externalData r:id="rId1">
-    <c:autoUpdate val="0"/>
-  </c:externalData>
-</c:chartSpace>
 </file>
 
 <file path=ppt/slideLayouts/slideLayout1.xml><?xml version="1.0" encoding="utf-8"?>
@@ -3257,138 +3088,354 @@
         <p:nvPr/>
       </p:nvGrpSpPr>
       <p:grpSpPr/>
-      <p:sp>
-        <p:nvSpPr>
-          <p:cNvPr id="2" name="Chart title"/>
-          <p:cNvSpPr txBox="1"/>
+      <p:grpSp>
+        <p:nvGrpSpPr>
+          <p:cNvPr id="12" name="FCF vs payouts chart"/>
+          <p:cNvGrpSpPr/>
           <p:nvPr/>
-        </p:nvSpPr>
-        <p:spPr>
+        </p:nvGrpSpPr>
+        <p:grpSpPr>
           <a:xfrm>
             <a:off x="3191256" y="3703320"/>
-            <a:ext cx="2743200" cy="274320"/>
+            <a:ext cx="2743200" cy="2103119"/>
+            <a:chOff x="3191256" y="3703320"/>
+            <a:chExt cx="2743200" cy="2103119"/>
           </a:xfrm>
-          <a:prstGeom prst="rect">
-            <a:avLst/>
-          </a:prstGeom>
-          <a:noFill/>
-        </p:spPr>
-        <p:txBody>
-          <a:bodyPr wrap="none" lIns="0" rIns="0">
-            <a:spAutoFit/>
-          </a:bodyPr>
-          <a:lstStyle/>
-          <a:p>
-            <a:pPr algn="ctr"/>
-            <a:r>
-              <a:rPr sz="1300">
-                <a:solidFill>
-                  <a:srgbClr val="000000"/>
-                </a:solidFill>
-                <a:latin typeface="Garamond"/>
-              </a:rPr>
-              <a:t>H1 FY26 Free Cash Flow vs. Payouts</a:t>
-            </a:r>
-          </a:p>
-        </p:txBody>
-      </p:sp>
-      <p:graphicFrame>
-        <p:nvGraphicFramePr>
-          <p:cNvPr id="3" name="FCF vs returns chart"/>
-          <p:cNvGraphicFramePr>
-            <a:graphicFrameLocks noGrp="1"/>
-          </p:cNvGraphicFramePr>
-          <p:nvPr/>
-        </p:nvGraphicFramePr>
-        <p:xfrm>
-          <a:off x="3191256" y="4023360"/>
-          <a:ext cx="2743200" cy="1600200"/>
-        </p:xfrm>
-        <a:graphic>
-          <a:graphicData uri="http://schemas.openxmlformats.org/drawingml/2006/chart">
-            <c:chart xmlns:c="http://schemas.openxmlformats.org/drawingml/2006/chart" r:id="rId2"/>
-          </a:graphicData>
-        </a:graphic>
-      </p:graphicFrame>
-      <p:sp>
-        <p:nvSpPr>
-          <p:cNvPr id="4" name="Chart caption"/>
-          <p:cNvSpPr txBox="1"/>
-          <p:nvPr/>
-        </p:nvSpPr>
-        <p:spPr>
-          <a:xfrm>
-            <a:off x="3191256" y="5641848"/>
-            <a:ext cx="2743200" cy="246888"/>
-          </a:xfrm>
-          <a:prstGeom prst="rect">
-            <a:avLst/>
-          </a:prstGeom>
-          <a:noFill/>
-        </p:spPr>
-        <p:txBody>
-          <a:bodyPr wrap="none" lIns="0" rIns="0">
-            <a:spAutoFit/>
-          </a:bodyPr>
-          <a:lstStyle/>
-          <a:p>
-            <a:pPr algn="ctr"/>
-            <a:r>
-              <a:rPr b="0" sz="1050">
-                <a:solidFill>
-                  <a:srgbClr val="666666"/>
-                </a:solidFill>
-                <a:latin typeface="Garamond"/>
-              </a:rPr>
-              <a:t>Dividends + buybacks = </a:t>
-            </a:r>
-            <a:r>
-              <a:rPr b="1" sz="1050">
-                <a:solidFill>
-                  <a:srgbClr val="000000"/>
-                </a:solidFill>
-                <a:latin typeface="Garamond"/>
-              </a:rPr>
-              <a:t>~2x FCF</a:t>
-            </a:r>
-          </a:p>
-        </p:txBody>
-      </p:sp>
-      <p:sp>
-        <p:nvSpPr>
-          <p:cNvPr id="5" name="Source"/>
-          <p:cNvSpPr txBox="1"/>
-          <p:nvPr/>
-        </p:nvSpPr>
-        <p:spPr>
-          <a:xfrm>
-            <a:off x="3191256" y="5897880"/>
-            <a:ext cx="2743200" cy="201168"/>
-          </a:xfrm>
-          <a:prstGeom prst="rect">
-            <a:avLst/>
-          </a:prstGeom>
-          <a:noFill/>
-        </p:spPr>
-        <p:txBody>
-          <a:bodyPr wrap="none" lIns="0" rIns="0">
-            <a:spAutoFit/>
-          </a:bodyPr>
-          <a:lstStyle/>
-          <a:p>
-            <a:pPr algn="ctr"/>
-            <a:r>
-              <a:rPr sz="800" i="1">
-                <a:solidFill>
-                  <a:srgbClr val="666666"/>
-                </a:solidFill>
-                <a:latin typeface="Garamond"/>
-              </a:rPr>
-              <a:t>Dividends $225M + buybacks $141M; FCF = $792M OCF – $614M capex</a:t>
-            </a:r>
-          </a:p>
-        </p:txBody>
-      </p:sp>
+        </p:grpSpPr>
+        <p:sp>
+          <p:nvSpPr>
+            <p:cNvPr id="2" name="Chart title"/>
+            <p:cNvSpPr txBox="1"/>
+            <p:nvPr/>
+          </p:nvSpPr>
+          <p:spPr>
+            <a:xfrm>
+              <a:off x="3191256" y="3703320"/>
+              <a:ext cx="2743200" cy="256032"/>
+            </a:xfrm>
+            <a:prstGeom prst="rect">
+              <a:avLst/>
+            </a:prstGeom>
+            <a:noFill/>
+          </p:spPr>
+          <p:txBody>
+            <a:bodyPr wrap="none" anchor="ctr" lIns="0" rIns="0" tIns="0" bIns="0">
+              <a:spAutoFit/>
+            </a:bodyPr>
+            <a:lstStyle/>
+            <a:p>
+              <a:pPr algn="ctr"/>
+              <a:r>
+                <a:rPr sz="1300" b="0" i="0">
+                  <a:solidFill>
+                    <a:srgbClr val="000000"/>
+                  </a:solidFill>
+                  <a:latin typeface="Garamond"/>
+                </a:rPr>
+                <a:t>H1 FY26 Cash Flow vs. Payouts ($M)</a:t>
+              </a:r>
+            </a:p>
+          </p:txBody>
+        </p:sp>
+        <p:sp>
+          <p:nvSpPr>
+            <p:cNvPr id="3" name="Label 1"/>
+            <p:cNvSpPr txBox="1"/>
+            <p:nvPr/>
+          </p:nvSpPr>
+          <p:spPr>
+            <a:xfrm>
+              <a:off x="3191256" y="4160520"/>
+              <a:ext cx="1261872" cy="420624"/>
+            </a:xfrm>
+            <a:prstGeom prst="rect">
+              <a:avLst/>
+            </a:prstGeom>
+            <a:noFill/>
+          </p:spPr>
+          <p:txBody>
+            <a:bodyPr wrap="none" anchor="ctr" lIns="0" rIns="0" tIns="0" bIns="0">
+              <a:spAutoFit/>
+            </a:bodyPr>
+            <a:lstStyle/>
+            <a:p>
+              <a:pPr algn="r"/>
+              <a:r>
+                <a:rPr sz="1100" b="0" i="0">
+                  <a:solidFill>
+                    <a:srgbClr val="666666"/>
+                  </a:solidFill>
+                  <a:latin typeface="Garamond"/>
+                </a:rPr>
+                <a:t>Free cash flow</a:t>
+              </a:r>
+            </a:p>
+          </p:txBody>
+        </p:sp>
+        <p:sp>
+          <p:nvSpPr>
+            <p:cNvPr id="4" name="Bar 1"/>
+            <p:cNvSpPr/>
+            <p:nvPr/>
+          </p:nvSpPr>
+          <p:spPr>
+            <a:xfrm>
+              <a:off x="4526280" y="4160520"/>
+              <a:ext cx="498073" cy="420624"/>
+            </a:xfrm>
+            <a:prstGeom prst="rect">
+              <a:avLst/>
+            </a:prstGeom>
+            <a:solidFill>
+              <a:srgbClr val="E06728"/>
+            </a:solidFill>
+            <a:ln>
+              <a:noFill/>
+            </a:ln>
+          </p:spPr>
+          <p:txBody>
+            <a:bodyPr rtlCol="0" anchor="ctr"/>
+            <a:lstStyle/>
+            <a:p>
+              <a:pPr algn="ctr"/>
+            </a:p>
+          </p:txBody>
+        </p:sp>
+        <p:sp>
+          <p:nvSpPr>
+            <p:cNvPr id="5" name="Value 1"/>
+            <p:cNvSpPr txBox="1"/>
+            <p:nvPr/>
+          </p:nvSpPr>
+          <p:spPr>
+            <a:xfrm>
+              <a:off x="5079217" y="4160520"/>
+              <a:ext cx="292608" cy="420624"/>
+            </a:xfrm>
+            <a:prstGeom prst="rect">
+              <a:avLst/>
+            </a:prstGeom>
+            <a:noFill/>
+          </p:spPr>
+          <p:txBody>
+            <a:bodyPr wrap="none" anchor="ctr" lIns="0" rIns="0" tIns="0" bIns="0">
+              <a:spAutoFit/>
+            </a:bodyPr>
+            <a:lstStyle/>
+            <a:p>
+              <a:pPr algn="l"/>
+              <a:r>
+                <a:rPr sz="1100" b="0" i="0">
+                  <a:solidFill>
+                    <a:srgbClr val="000000"/>
+                  </a:solidFill>
+                  <a:latin typeface="Garamond"/>
+                </a:rPr>
+                <a:t>178</a:t>
+              </a:r>
+            </a:p>
+          </p:txBody>
+        </p:sp>
+        <p:sp>
+          <p:nvSpPr>
+            <p:cNvPr id="6" name="Label 2"/>
+            <p:cNvSpPr txBox="1"/>
+            <p:nvPr/>
+          </p:nvSpPr>
+          <p:spPr>
+            <a:xfrm>
+              <a:off x="3191256" y="4782312"/>
+              <a:ext cx="1261872" cy="420624"/>
+            </a:xfrm>
+            <a:prstGeom prst="rect">
+              <a:avLst/>
+            </a:prstGeom>
+            <a:noFill/>
+          </p:spPr>
+          <p:txBody>
+            <a:bodyPr wrap="none" anchor="ctr" lIns="0" rIns="0" tIns="0" bIns="0">
+              <a:spAutoFit/>
+            </a:bodyPr>
+            <a:lstStyle/>
+            <a:p>
+              <a:pPr algn="r"/>
+              <a:r>
+                <a:rPr sz="1100" b="0" i="0">
+                  <a:solidFill>
+                    <a:srgbClr val="666666"/>
+                  </a:solidFill>
+                  <a:latin typeface="Garamond"/>
+                </a:rPr>
+                <a:t>Dividends + buybacks</a:t>
+              </a:r>
+            </a:p>
+          </p:txBody>
+        </p:sp>
+        <p:sp>
+          <p:nvSpPr>
+            <p:cNvPr id="7" name="Bar 2"/>
+            <p:cNvSpPr/>
+            <p:nvPr/>
+          </p:nvSpPr>
+          <p:spPr>
+            <a:xfrm>
+              <a:off x="4526280" y="4782312"/>
+              <a:ext cx="1024128" cy="420624"/>
+            </a:xfrm>
+            <a:prstGeom prst="rect">
+              <a:avLst/>
+            </a:prstGeom>
+            <a:solidFill>
+              <a:srgbClr val="161E40"/>
+            </a:solidFill>
+            <a:ln>
+              <a:noFill/>
+            </a:ln>
+          </p:spPr>
+          <p:txBody>
+            <a:bodyPr rtlCol="0" anchor="ctr"/>
+            <a:lstStyle/>
+            <a:p>
+              <a:pPr algn="ctr"/>
+            </a:p>
+          </p:txBody>
+        </p:sp>
+        <p:sp>
+          <p:nvSpPr>
+            <p:cNvPr id="8" name="Value 2"/>
+            <p:cNvSpPr txBox="1"/>
+            <p:nvPr/>
+          </p:nvSpPr>
+          <p:spPr>
+            <a:xfrm>
+              <a:off x="5605272" y="4782312"/>
+              <a:ext cx="292608" cy="420624"/>
+            </a:xfrm>
+            <a:prstGeom prst="rect">
+              <a:avLst/>
+            </a:prstGeom>
+            <a:noFill/>
+          </p:spPr>
+          <p:txBody>
+            <a:bodyPr wrap="none" anchor="ctr" lIns="0" rIns="0" tIns="0" bIns="0">
+              <a:spAutoFit/>
+            </a:bodyPr>
+            <a:lstStyle/>
+            <a:p>
+              <a:pPr algn="l"/>
+              <a:r>
+                <a:rPr sz="1100" b="0" i="0">
+                  <a:solidFill>
+                    <a:srgbClr val="000000"/>
+                  </a:solidFill>
+                  <a:latin typeface="Garamond"/>
+                </a:rPr>
+                <a:t>366</a:t>
+              </a:r>
+            </a:p>
+          </p:txBody>
+        </p:sp>
+        <p:cxnSp>
+          <p:nvCxnSpPr>
+            <p:cNvPr id="9" name="Baseline"/>
+            <p:cNvCxnSpPr/>
+            <p:nvPr/>
+          </p:nvCxnSpPr>
+          <p:spPr>
+            <a:xfrm>
+              <a:off x="4526280" y="4069080"/>
+              <a:ext cx="0" cy="1225295"/>
+            </a:xfrm>
+            <a:prstGeom prst="line">
+              <a:avLst/>
+            </a:prstGeom>
+            <a:ln w="9525">
+              <a:solidFill>
+                <a:srgbClr val="D9D9D9"/>
+              </a:solidFill>
+            </a:ln>
+          </p:spPr>
+        </p:cxnSp>
+        <p:sp>
+          <p:nvSpPr>
+            <p:cNvPr id="10" name="Caption"/>
+            <p:cNvSpPr txBox="1"/>
+            <p:nvPr/>
+          </p:nvSpPr>
+          <p:spPr>
+            <a:xfrm>
+              <a:off x="3191256" y="5385816"/>
+              <a:ext cx="2743200" cy="219456"/>
+            </a:xfrm>
+            <a:prstGeom prst="rect">
+              <a:avLst/>
+            </a:prstGeom>
+            <a:noFill/>
+          </p:spPr>
+          <p:txBody>
+            <a:bodyPr wrap="none" anchor="ctr" lIns="0" rIns="0" tIns="0" bIns="0">
+              <a:spAutoFit/>
+            </a:bodyPr>
+            <a:lstStyle/>
+            <a:p>
+              <a:pPr algn="ctr"/>
+              <a:r>
+                <a:rPr sz="1050" b="0" i="0">
+                  <a:solidFill>
+                    <a:srgbClr val="666666"/>
+                  </a:solidFill>
+                  <a:latin typeface="Garamond"/>
+                </a:rPr>
+                <a:t>Dividends $225M + buybacks $141M = </a:t>
+              </a:r>
+              <a:r>
+                <a:rPr sz="1050" b="1" i="0">
+                  <a:solidFill>
+                    <a:srgbClr val="000000"/>
+                  </a:solidFill>
+                  <a:latin typeface="Garamond"/>
+                </a:rPr>
+                <a:t>~2x FCF</a:t>
+              </a:r>
+            </a:p>
+          </p:txBody>
+        </p:sp>
+        <p:sp>
+          <p:nvSpPr>
+            <p:cNvPr id="11" name="Source"/>
+            <p:cNvSpPr txBox="1"/>
+            <p:nvPr/>
+          </p:nvSpPr>
+          <p:spPr>
+            <a:xfrm>
+              <a:off x="3191256" y="5623559"/>
+              <a:ext cx="2743200" cy="182880"/>
+            </a:xfrm>
+            <a:prstGeom prst="rect">
+              <a:avLst/>
+            </a:prstGeom>
+            <a:noFill/>
+          </p:spPr>
+          <p:txBody>
+            <a:bodyPr wrap="none" anchor="ctr" lIns="0" rIns="0" tIns="0" bIns="0">
+              <a:spAutoFit/>
+            </a:bodyPr>
+            <a:lstStyle/>
+            <a:p>
+              <a:pPr algn="ctr"/>
+              <a:r>
+                <a:rPr sz="800" b="0" i="1">
+                  <a:solidFill>
+                    <a:srgbClr val="666666"/>
+                  </a:solidFill>
+                  <a:latin typeface="Garamond"/>
+                </a:rPr>
+                <a:t>FCF = $792M operating cash flow – $614M capex (team calc.)</a:t>
+              </a:r>
+            </a:p>
+          </p:txBody>
+        </p:sp>
+      </p:grpSp>
     </p:spTree>
   </p:cSld>
   <p:clrMapOvr>

</xml_diff>